<commit_message>
VeriQ v2: merge external review corrections into Case 3 design and slide
- Three-speed design: fast guardrails, regime-aware receipts (improved/degraded/
  inconclusive), causal claims only from randomised repeated experiments
- Fault localisation (WAN / remote path / Wi-Fi / bad probe) before any action
- Real floors via HTB guaranteed mode and budgeted intent leases; CAKE as default
- Correct conformal reporting, estimated-MOS labelling, precise privacy statement
- Real tuned baselines (SQM-CAKE, cake-autorate v3.2) plus ablations; MVP vs stretch scope

Co-Authored-By: Claude Opus 5.5 <noreply@anthropic.com>
Claude-Session: https://claude.ai/code/session_01BHtCR8smcTiZYcbgGiehoM
</commit_message>
<xml_diff>
--- a/submission/Round1_Case3_VeriQ.pptx
+++ b/submission/Round1_Case3_VeriQ.pptx
@@ -6182,7 +6182,7 @@
                   <a:srgbClr val="12233D"/>
                 </a:solidFill>
               </a:rPr>
-              <a:t>VeriQ: Experience-Verified, Intent-Aware QoS</a:t>
+              <a:t>VeriQ: adapts, measures, explains</a:t>
             </a:r>
           </a:p>
         </p:txBody>
@@ -6360,7 +6360,7 @@
                 </a:solidFill>
                 <a:latin typeface="Calibri"/>
               </a:rPr>
-              <a:t>: Experience-Verified, Intent-Aware QoS for the mixed-traffic home</a:t>
+              <a:t>: intent-aware home QoS with measurable outcomes &amp; explainable recovery</a:t>
             </a:r>
           </a:p>
           <a:p>
@@ -6478,7 +6478,7 @@
                 </a:solidFill>
                 <a:latin typeface="Calibri"/>
               </a:rPr>
-              <a:t>Queues, not bandwidth: a backup upload filled the modem's oversized FIFO and added 266 ms (p95) to every packet in our Day-0 lab (emulated, 5 Mbit up)</a:t>
+              <a:t>Queues, not bandwidth: a backup upload filled the modem's oversized FIFO and added 266 ms (p95) in our Day-0 lab (emulated, 5 Mbit up); fq_codel alone can't reach that queue</a:t>
             </a:r>
           </a:p>
           <a:p>
@@ -6603,7 +6603,7 @@
                 </a:solidFill>
                 <a:latin typeface="Calibri"/>
               </a:rPr>
-              <a:t>“Other QoS engines guess. VeriQ verifies.”</a:t>
+              <a:t>“VeriQ adapts, measures, and explains.”</a:t>
             </a:r>
           </a:p>
           <a:p>
@@ -6613,49 +6613,40 @@
               </a:spcAft>
             </a:pPr>
             <a:r>
-              <a:rPr sz="1050" b="0">
+              <a:rPr sz="1050" b="1">
                 <a:solidFill>
                   <a:srgbClr val="222B38"/>
                 </a:solidFill>
                 <a:latin typeface="Calibri"/>
               </a:rPr>
-              <a:t>Every policy change is a hypothesis: applied as a </a:t>
-            </a:r>
-            <a:r>
-              <a:rPr sz="1050" b="1">
+              <a:t>Localise the fault first</a:t>
+            </a:r>
+            <a:r>
+              <a:rPr sz="1050" b="0">
                 <a:solidFill>
                   <a:srgbClr val="222B38"/>
                 </a:solidFill>
                 <a:latin typeface="Calibri"/>
               </a:rPr>
-              <a:t>canary</a:t>
-            </a:r>
-            <a:r>
-              <a:rPr sz="1050" b="0">
+              <a:t> (own queue, WAN drop, remote path, Wi-Fi, bad probe), then act with bounded fast guardrails. Every adaptation gets an </a:t>
+            </a:r>
+            <a:r>
+              <a:rPr sz="1050" b="1">
                 <a:solidFill>
                   <a:srgbClr val="222B38"/>
                 </a:solidFill>
                 <a:latin typeface="Calibri"/>
               </a:rPr>
-              <a:t>, tested on real experience metrics, kept only if it measurably helps, otherwise </a:t>
-            </a:r>
-            <a:r>
-              <a:rPr sz="1050" b="1">
+              <a:t>experience receipt: improved / degraded / inconclusive</a:t>
+            </a:r>
+            <a:r>
+              <a:rPr sz="1050" b="0">
                 <a:solidFill>
                   <a:srgbClr val="222B38"/>
                 </a:solidFill>
                 <a:latin typeface="Calibri"/>
               </a:rPr>
-              <a:t>rolled back automatically</a:t>
-            </a:r>
-            <a:r>
-              <a:rPr sz="1050" b="0">
-                <a:solidFill>
-                  <a:srgbClr val="222B38"/>
-                </a:solidFill>
-                <a:latin typeface="Calibri"/>
-              </a:rPr>
-              <a:t>, with an experience receipt.</a:t>
+              <a:t>, measured on real calls and video.</a:t>
             </a:r>
           </a:p>
         </p:txBody>
@@ -6714,7 +6705,7 @@
                 </a:solidFill>
                 <a:latin typeface="Calibri"/>
               </a:rPr>
-              <a:t>Safety by design</a:t>
+              <a:t>Bounded by design</a:t>
             </a:r>
           </a:p>
           <a:p>
@@ -6739,7 +6730,7 @@
                 </a:solidFill>
                 <a:latin typeface="Calibri"/>
               </a:rPr>
-              <a:t>Never reads payload: headers + timing only; IPv4 + IPv6</a:t>
+              <a:t>Never inspects forwarded payload; headers + timing; IPv4 + IPv6</a:t>
             </a:r>
           </a:p>
           <a:p>
@@ -6764,7 +6755,7 @@
                 </a:solidFill>
                 <a:latin typeface="Calibri"/>
               </a:rPr>
-              <a:t>Every class keeps a non-zero floor: no starvation</a:t>
+              <a:t>Intents = expiring leases with real HTB guaranteed rates from a budget; progress measured</a:t>
             </a:r>
           </a:p>
           <a:p>
@@ -6789,7 +6780,7 @@
                 </a:solidFill>
                 <a:latin typeface="Calibri"/>
               </a:rPr>
-              <a:t>Abstains when unsure (conformal confidence)</a:t>
+              <a:t>Abstains when unsure: never promotes an uncertain flow</a:t>
             </a:r>
           </a:p>
           <a:p>
@@ -6814,7 +6805,7 @@
                 </a:solidFill>
                 <a:latin typeface="Calibri"/>
               </a:rPr>
-              <a:t>Versioned, reversible policies; watchdog → known-safe profile in &lt; 1 s</a:t>
+              <a:t>Versioned, read-back config; watchdog → conservative SAFE shaper</a:t>
             </a:r>
           </a:p>
         </p:txBody>
@@ -6869,7 +6860,7 @@
                 </a:solidFill>
                 <a:latin typeface="Calibri"/>
               </a:rPr>
-              <a:t>Closed loop: observe → understand → decide → enforce → verify → commit or roll back</a:t>
+              <a:t>Three speeds: fast guardrails (sub-second) · outcome receipts (tens of seconds) · controlled experiments (lab, for claims)</a:t>
             </a:r>
           </a:p>
         </p:txBody>
@@ -6944,7 +6935,7 @@
                 </a:solidFill>
                 <a:latin typeface="Calibri"/>
               </a:rPr>
-              <a:t>eBPF flow observer on tc clsact: sizes, timing, direction of first 30 packets; v4/v6; no payload</a:t>
+              <a:t>Header + timing features of first packets per flow; v4/v6; no payload</a:t>
             </a:r>
           </a:p>
         </p:txBody>
@@ -7063,7 +7054,7 @@
                 </a:solidFill>
                 <a:latin typeface="Calibri"/>
               </a:rPr>
-              <a:t>Early classifier with calibrated conformal confidence + capacity estimator (one-way-delay / STAMP probes, change-point)</a:t>
+              <a:t>Early calibrated classifier (abstains) + capacity estimate μ ± σ + fault localiser (near/far probes)</a:t>
             </a:r>
           </a:p>
         </p:txBody>
@@ -7182,7 +7173,7 @@
                 </a:solidFill>
                 <a:latin typeface="Calibri"/>
               </a:rPr>
-              <a:t>Control loop on queuing delay · shaper = μ − kσ · intents with TTL · fairness floors</a:t>
+              <a:t>Bounded guardrails: shaper = μ − kσ, change-point fast path · leases within budget</a:t>
             </a:r>
           </a:p>
         </p:txBody>
@@ -7301,7 +7292,7 @@
                 </a:solidFill>
                 <a:latin typeface="Calibri"/>
               </a:rPr>
-              <a:t>CAKE / HTB via netlink: transactional apply, readback, rollback</a:t>
+              <a:t>CAKE (default) or HTB guaranteed mode; ordered, versioned, read-back apply</a:t>
             </a:r>
           </a:p>
         </p:txBody>
@@ -7404,7 +7395,7 @@
                 </a:solidFill>
                 <a:latin typeface="Calibri"/>
               </a:rPr>
-              <a:t>Verify</a:t>
+              <a:t>Assess</a:t>
             </a:r>
           </a:p>
           <a:p>
@@ -7420,7 +7411,7 @@
                 </a:solidFill>
                 <a:latin typeface="Calibri"/>
               </a:rPr>
-              <a:t>Canary statistics on E-model MOS, WebRTC freezes, IETF RPM, Jain fairness</a:t>
+              <a:t>Receipts on WebRTC freezes, DASH rebuffers, delay, progress; estimated MOS labelled</a:t>
             </a:r>
           </a:p>
         </p:txBody>
@@ -7523,7 +7514,7 @@
                 </a:solidFill>
                 <a:latin typeface="Calibri"/>
               </a:rPr>
-              <a:t>Show &amp; control</a:t>
+              <a:t>Show</a:t>
             </a:r>
           </a:p>
           <a:p>
@@ -7539,7 +7530,7 @@
                 </a:solidFill>
                 <a:latin typeface="Calibri"/>
               </a:rPr>
-              <a:t>Grafana · live 3D home-network twin · intent API (REST, TR-181 / USP)</a:t>
+              <a:t>Grafana · 3D twin + replay: measured / estimated / illustrative</a:t>
             </a:r>
           </a:p>
         </p:txBody>
@@ -7614,7 +7605,7 @@
                 </a:solidFill>
                 <a:latin typeface="Calibri"/>
               </a:rPr>
-              <a:t>1  Experience-verified policy transactions: </a:t>
+              <a:t>1  Fault localisation before action: </a:t>
             </a:r>
             <a:r>
               <a:rPr sz="1050" b="0">
@@ -7623,7 +7614,7 @@
                 </a:solidFill>
                 <a:latin typeface="Calibri"/>
               </a:rPr>
-              <a:t>canary → bootstrap CI / Mann-Whitney on p95 delay and MOS → commit or auto-rollback, each with a receipt</a:t>
+              <a:t>WAN drop vs remote path vs Wi-Fi vs lying probe, scored against emulator ground truth; a remote slowdown never triggers a wasteful cut</a:t>
             </a:r>
           </a:p>
           <a:p>
@@ -7673,7 +7664,7 @@
                 </a:solidFill>
                 <a:latin typeface="Calibri"/>
               </a:rPr>
-              <a:t>conformal sets → abstain when unsure; one-click correction feeds retraining; accuracy reported per privacy tier</a:t>
+              <a:t>conformal sets; we report coverage, selective accuracy and abstention separately, including under traffic shift</a:t>
             </a:r>
           </a:p>
           <a:p>
@@ -7689,7 +7680,7 @@
                 </a:solidFill>
                 <a:latin typeface="Calibri"/>
               </a:rPr>
-              <a:t>4  Uncertainty-aware capacity tracking: </a:t>
+              <a:t>4  Honest receipts + replay: </a:t>
             </a:r>
             <a:r>
               <a:rPr sz="1050" b="0">
@@ -7698,7 +7689,7 @@
                 </a:solidFill>
                 <a:latin typeface="Calibri"/>
               </a:rPr>
-              <a:t>Bayesian change-point + delay probes, up and down separately, link-layer overhead compensated</a:t>
+              <a:t>improved / degraded / inconclusive, regime-aware; 3D replay shows inferred vs true ISP queue side by side</a:t>
             </a:r>
           </a:p>
         </p:txBody>
@@ -7782,7 +7773,7 @@
                 </a:solidFill>
                 <a:latin typeface="Calibri"/>
               </a:rPr>
-              <a:t>One-command netns lab, 5 arms: FIFO · fq_codel · static CAKE (SQM) · cake-autorate-style · VeriQ; ≥10 runs, 95% CIs, auto PDF report</a:t>
+              <a:t>Real, tuned baselines: FIFO · fq_codel · SQM-CAKE · cake-autorate v3.2 · VeriQ + ablations; ≥10 randomised runs, 95% CIs</a:t>
             </a:r>
           </a:p>
           <a:p>
@@ -7807,7 +7798,7 @@
                 </a:solidFill>
                 <a:latin typeface="Calibri"/>
               </a:rPr>
-              <a:t>8 scenarios: ISO during a call, 100 → 20 Mbps drop, 3 TVs + gaming, backup upload, chaos kill, IPv6…</a:t>
+              <a:t>9 scenarios: ISO during call, 100 → 20 Mbps drop, 3 TVs + gaming, remote-path delay, lying probe, crash, IPv6…</a:t>
             </a:r>
           </a:p>
           <a:p>
@@ -7832,7 +7823,7 @@
                 </a:solidFill>
                 <a:latin typeface="Calibri"/>
               </a:rPr>
-              <a:t>Live physical kit: Raspberry Pi 5 router + red “WAN DROP” button + chaos button</a:t>
+              <a:t>Physical Pi 5 kit: the judge picks the fault, VeriQ responds from telemetry alone</a:t>
             </a:r>
           </a:p>
           <a:p>
@@ -7857,7 +7848,7 @@
                 </a:solidFill>
                 <a:latin typeface="Calibri"/>
               </a:rPr>
-              <a:t>real-time added delay p95 ≤ 10 ms · settle &lt; 2 s after WAN drop · zero starvation · CPU measured on ARM</a:t>
+              <a:t>0 call freezes in S1 · added delay p95 ≤ 10 ms · settle &lt; 2 s after WAN drop · measured progress for every class</a:t>
             </a:r>
           </a:p>
         </p:txBody>
@@ -7925,7 +7916,7 @@
                 </a:solidFill>
                 <a:latin typeface="Calibri"/>
               </a:rPr>
-              <a:t>Linux tc (CAKE · HTB · fq_codel; DualPI2/L4S-ready) · eBPF (libbpf CO-RE) · Python/Go control plane · LightGBM + conformal · Prometheus/Grafana · React + three.js · Flent / irtt / iperf3 / Playwright</a:t>
+              <a:t>Linux tc (CAKE · HTB · fq_codel) · Python + pyroute2 control plane · LightGBM + conformal · Prometheus/Grafana · React + three.js · Playwright (WebRTC, dash.js) · iperf3 / irtt / Flent</a:t>
             </a:r>
           </a:p>
           <a:p>
@@ -7941,7 +7932,7 @@
                 </a:solidFill>
                 <a:latin typeface="Calibri"/>
               </a:rPr>
-              <a:t>Industry path: </a:t>
+              <a:t>Industry path (designed, not built): </a:t>
             </a:r>
             <a:r>
               <a:rPr sz="950" b="0">
@@ -7950,7 +7941,7 @@
                 </a:solidFill>
                 <a:latin typeface="Calibri"/>
               </a:rPr>
-              <a:t>RDK-B / OpenWrt package · TR-181 data model + TR-369 USP for fleet control · EDT + eBPF + sch_fq for multi-gig PON · closed-loop home edge for intent-based network ops</a:t>
+              <a:t>RDK-B / OpenWrt package · TR-181 + TR-369 USP fleet management · research tracks: eBPF datapath, Wi-Fi airtime, L4S, multi-gig scaling</a:t>
             </a:r>
           </a:p>
         </p:txBody>

</xml_diff>

<commit_message>
VeriQ v3.1: locked core plus verified upgrades from the v3 research pass
- Core adds marks-first classification, classifier honesty kit, cake-autorate
  starting values, bounded fallback under uncertain diagnosis, UDPST idle probe
  (RFC 9946), shadow mode + decision log + health states, RPM bands, offline QoO
- Corrections: overlapping probes (no segment sums), ECN/CE wording, QoO
  statistics and coverage rules, exact HTB lease budget, no NQB/L4S lane sharing
- NQB lane, DualPI2, header-only call estimator, live QoO, chat box moved post-core
- Harness-first build order, tiered run matrix, scenarios S10-S13
- docs/08 decision log; guide chapter 21; slide and playbook updated

Co-Authored-By: Claude Opus 5.5 <noreply@anthropic.com>
Claude-Session: https://claude.ai/code/session_01BHtCR8smcTiZYcbgGiehoM
</commit_message>
<xml_diff>
--- a/submission/Round1_Case3_VeriQ.pptx
+++ b/submission/Round1_Case3_VeriQ.pptx
@@ -6597,13 +6597,13 @@
               </a:spcAft>
             </a:pPr>
             <a:r>
-              <a:rPr sz="1150" b="1">
+              <a:rPr sz="1100" b="1">
                 <a:solidFill>
                   <a:srgbClr val="12233D"/>
                 </a:solidFill>
                 <a:latin typeface="Calibri"/>
               </a:rPr>
-              <a:t>“VeriQ adapts, measures, and explains.”</a:t>
+              <a:t>“VeriQ finds the cause, protects what you chose, and proves it.”</a:t>
             </a:r>
           </a:p>
           <a:p>
@@ -6805,7 +6805,7 @@
                 </a:solidFill>
                 <a:latin typeface="Calibri"/>
               </a:rPr>
-              <a:t>Versioned, read-back config; watchdog → conservative SAFE shaper</a:t>
+              <a:t>Shadow mode first; every decision logged; watchdog → SAFE shaper</a:t>
             </a:r>
           </a:p>
         </p:txBody>
@@ -6935,7 +6935,7 @@
                 </a:solidFill>
                 <a:latin typeface="Calibri"/>
               </a:rPr>
-              <a:t>Header + timing features of first packets per flow; v4/v6; no payload</a:t>
+              <a:t>Header + timing of first packets per flow, app marks (NQB / L4S); v4/v6; no payload</a:t>
             </a:r>
           </a:p>
         </p:txBody>
@@ -7054,7 +7054,7 @@
                 </a:solidFill>
                 <a:latin typeface="Calibri"/>
               </a:rPr>
-              <a:t>Early calibrated classifier (abstains) + capacity μ ± σ (delay tracking + active packet-train probes) + fault localiser</a:t>
+              <a:t>Marks first, then a calibrated classifier (abstains) · capacity μ ± σ + UDPST idle test (RFC 9946) · fault localiser</a:t>
             </a:r>
           </a:p>
         </p:txBody>
@@ -7664,7 +7664,7 @@
                 </a:solidFill>
                 <a:latin typeface="Calibri"/>
               </a:rPr>
-              <a:t>conformal sets; we report coverage, selective accuracy and abstention separately, including under traffic shift</a:t>
+              <a:t>marks first; split by flow and by time, no shortcut features (SIGCOMM 2025 lesson); abstains when unsure</a:t>
             </a:r>
           </a:p>
           <a:p>
@@ -7689,7 +7689,7 @@
                 </a:solidFill>
                 <a:latin typeface="Calibri"/>
               </a:rPr>
-              <a:t>improved / degraded / inconclusive, regime-aware; 3D replay shows inferred vs true ISP queue side by side</a:t>
+              <a:t>improved / degraded / inconclusive, plus IETF Quality-of-Outcome scores; 3D replay shows inferred vs true ISP queue</a:t>
             </a:r>
           </a:p>
         </p:txBody>
@@ -7773,7 +7773,7 @@
                 </a:solidFill>
                 <a:latin typeface="Calibri"/>
               </a:rPr>
-              <a:t>Real, tuned baselines: FIFO · fq_codel · SQM-CAKE · cake-autorate v3.2 · VeriQ + ablations; ≥10 randomised runs, 95% CIs</a:t>
+              <a:t>Real, tuned baselines: FIFO · fq_codel · SQM-CAKE · cake-autorate · qosify-style rules + ablations; ≥10 randomised runs, 95% CIs</a:t>
             </a:r>
           </a:p>
           <a:p>
@@ -7798,7 +7798,7 @@
                 </a:solidFill>
                 <a:latin typeface="Calibri"/>
               </a:rPr>
-              <a:t>9 scenarios: ISO during call, 100 → 20 Mbps drop, 3 TVs + gaming, remote-path delay, lying probe, crash, IPv6…</a:t>
+              <a:t>13 scenarios: ISO during call, 100 → 20 Mbps drop, 3 TVs + gaming, remote delay, Wi-Fi, false marks, crash, IPv6…</a:t>
             </a:r>
           </a:p>
           <a:p>

</xml_diff>

<commit_message>
VeriQ v3.2: five final corrections
- CAKE-only core: HTB reservations and scheduler switching moved post-core;
  core leases give bounded preferential treatment (CAKE tin thresholds)
- Uncertainty fallback fully specified: episode/reset rule, 5% steps, 10%
  cumulative cap per rolling 10 min, fixed windows, mechanism check,
  throughput guard, INCONCLUSIVE -> revert
- Traffic-protection sanctions take precedence over classifier, corrections
  and leases, with a penalty-period recovery rule
- p99.9 wording; unknown throughput withholds full QoO (partial label)
- Guide, decisions log, playbook Q&A, slide and README updated

Co-Authored-By: Claude Opus 5.5 <noreply@anthropic.com>
Claude-Session: https://claude.ai/code/session_01BHtCR8smcTiZYcbgGiehoM
</commit_message>
<xml_diff>
--- a/submission/Round1_Case3_VeriQ.pptx
+++ b/submission/Round1_Case3_VeriQ.pptx
@@ -6755,7 +6755,7 @@
                 </a:solidFill>
                 <a:latin typeface="Calibri"/>
               </a:rPr>
-              <a:t>Intents = expiring leases with real HTB guaranteed rates from a budget; progress measured</a:t>
+              <a:t>Intents = expiring, budgeted leases; CAKE caps any boost; misbehaving flows sanctioned; progress measured</a:t>
             </a:r>
           </a:p>
           <a:p>
@@ -7292,7 +7292,7 @@
                 </a:solidFill>
                 <a:latin typeface="Calibri"/>
               </a:rPr>
-              <a:t>CAKE (default) or HTB guaranteed mode; ordered, versioned, read-back apply</a:t>
+              <a:t>CAKE with bounded lease boosts; ordered, versioned, read-back apply</a:t>
             </a:r>
           </a:p>
         </p:txBody>
@@ -7916,7 +7916,7 @@
                 </a:solidFill>
                 <a:latin typeface="Calibri"/>
               </a:rPr>
-              <a:t>Linux tc (CAKE · HTB · fq_codel) · Python + pyroute2 control plane · LightGBM + conformal · Prometheus/Grafana · React + three.js · Playwright (WebRTC, dash.js) · iperf3 / irtt / Flent</a:t>
+              <a:t>Linux tc (CAKE; HTB later) · Python + pyroute2 control plane · LightGBM + conformal · Prometheus/Grafana · React + three.js · Playwright (WebRTC, dash.js) · iperf3 / irtt / Flent</a:t>
             </a:r>
           </a:p>
           <a:p>

</xml_diff>

<commit_message>
VeriQ v3.3 final pre-build corrections and judge-facing project description
- CAKE tin thresholds described as weight changes, not caps or reservations;
  two-lease limit marked provisional
- Minimal WebRTC/DASH harness moved into the first milestone
- Diagnoses worded as evidence consistent with..., with corroboration rules;
  unmeasured validations marked planned
- Uncertainty fallback framed as a hypothesis; router-queue change is
  supporting evidence; condition-aware undo; sanction cap and recovery test
- New docs/VeriQ_Project_Description.pdf (19 pages) and its builder

Co-Authored-By: Claude Opus 5.5 <noreply@anthropic.com>
Claude-Session: https://claude.ai/code/session_01BHtCR8smcTiZYcbgGiehoM
</commit_message>
<xml_diff>
--- a/submission/Round1_Case3_VeriQ.pptx
+++ b/submission/Round1_Case3_VeriQ.pptx
@@ -6755,7 +6755,7 @@
                 </a:solidFill>
                 <a:latin typeface="Calibri"/>
               </a:rPr>
-              <a:t>Intents = expiring, budgeted leases; CAKE caps any boost; misbehaving flows sanctioned; progress measured</a:t>
+              <a:t>Intents = expiring leases selecting preferential CAKE treatment; misbehaving flows sanctioned; fairness measured</a:t>
             </a:r>
           </a:p>
           <a:p>
@@ -7292,7 +7292,7 @@
                 </a:solidFill>
                 <a:latin typeface="Calibri"/>
               </a:rPr>
-              <a:t>CAKE with bounded lease boosts; ordered, versioned, read-back apply</a:t>
+              <a:t>CAKE; leases select preferential tins; ordered, versioned, read-back apply</a:t>
             </a:r>
           </a:p>
         </p:txBody>

</xml_diff>

<commit_message>
VeriQ v5: final design spec, change record, handbook sources/figures/build pipeline (WIP), Round 1 slide synced to v5
Co-Authored-By: Claude Opus 5.5 <noreply@anthropic.com>
Claude-Session: https://claude.ai/code/session_01BHtCR8smcTiZYcbgGiehoM
</commit_message>
<xml_diff>
--- a/submission/Round1_Case3_VeriQ.pptx
+++ b/submission/Round1_Case3_VeriQ.pptx
@@ -6637,7 +6637,7 @@
                 </a:solidFill>
                 <a:latin typeface="Calibri"/>
               </a:rPr>
-              <a:t>experience receipt: improved / degraded / inconclusive</a:t>
+              <a:t>experience receipt: improved / not improved / inconclusive</a:t>
             </a:r>
             <a:r>
               <a:rPr sz="1050" b="0">
@@ -6780,7 +6780,7 @@
                 </a:solidFill>
                 <a:latin typeface="Calibri"/>
               </a:rPr>
-              <a:t>Abstains when unsure: never promotes an uncertain flow</a:t>
+              <a:t>Abstention alone never grants priority; leases are explicit, authenticated, expiring</a:t>
             </a:r>
           </a:p>
           <a:p>
@@ -6805,7 +6805,7 @@
                 </a:solidFill>
                 <a:latin typeface="Calibri"/>
               </a:rPr>
-              <a:t>Shadow mode first; every decision logged; watchdog → SAFE shaper</a:t>
+              <a:t>Shadow mode first; decisions logged; watchdog → SAFE</a:t>
             </a:r>
           </a:p>
         </p:txBody>
@@ -7173,7 +7173,7 @@
                 </a:solidFill>
                 <a:latin typeface="Calibri"/>
               </a:rPr>
-              <a:t>Bounded guardrails: shaper = μ − kσ, change-point fast path · leases within budget</a:t>
+              <a:t>Evidence-graded: one-step cut to 0.9·Ĝ only with 2 independent sources; else hold or bounded fallback</a:t>
             </a:r>
           </a:p>
         </p:txBody>
@@ -7292,7 +7292,7 @@
                 </a:solidFill>
                 <a:latin typeface="Calibri"/>
               </a:rPr>
-              <a:t>CAKE; leases select preferential tins; ordered, versioned, read-back apply</a:t>
+              <a:t>Action Checker admits each step → CAKE fwmark tins; ordered, read-back apply</a:t>
             </a:r>
           </a:p>
         </p:txBody>
@@ -7614,7 +7614,7 @@
                 </a:solidFill>
                 <a:latin typeface="Calibri"/>
               </a:rPr>
-              <a:t>WAN drop vs remote path vs Wi-Fi vs lying probe, scored against emulator ground truth; a remote slowdown never triggers a wasteful cut</a:t>
+              <a:t>WAN drop vs remote path vs Wi-Fi vs lying probe, scored against emulator ground truth; designed to hold when a cut cannot help (measured as inappropriate interventions)</a:t>
             </a:r>
           </a:p>
           <a:p>
@@ -7689,7 +7689,7 @@
                 </a:solidFill>
                 <a:latin typeface="Calibri"/>
               </a:rPr>
-              <a:t>improved / degraded / inconclusive, plus IETF Quality-of-Outcome scores; 3D replay shows inferred vs true ISP queue</a:t>
+              <a:t>improved / not improved / inconclusive, plus offline Quality-of-Outcome scores; 3D replay shows inferred vs true ISP queue</a:t>
             </a:r>
           </a:p>
         </p:txBody>
@@ -7773,7 +7773,7 @@
                 </a:solidFill>
                 <a:latin typeface="Calibri"/>
               </a:rPr>
-              <a:t>Real, tuned baselines: FIFO · fq_codel · SQM-CAKE · cake-autorate · qosify-style rules + ablations; ≥10 randomised runs, 95% CIs</a:t>
+              <a:t>Pinned, tuned baselines: SQM-CAKE · cake-autorate · QoSmate (+autorate) · ablations; run = unit, bootstrap CIs, blind faults</a:t>
             </a:r>
           </a:p>
           <a:p>
@@ -7798,7 +7798,7 @@
                 </a:solidFill>
                 <a:latin typeface="Calibri"/>
               </a:rPr>
-              <a:t>13 scenarios: ISO during call, 100 → 20 Mbps drop, 3 TVs + gaming, remote delay, Wi-Fi, false marks, crash, IPv6…</a:t>
+              <a:t>13 core scenarios + 32 adverse conditions: 100 → 20 Mbps drop, remote delay, lying/lost reflectors, Wi-Fi, CPU, crash, IPv6…</a:t>
             </a:r>
           </a:p>
           <a:p>
@@ -7848,7 +7848,7 @@
                 </a:solidFill>
                 <a:latin typeface="Calibri"/>
               </a:rPr>
-              <a:t>0 call freezes in S1 · added delay p95 ≤ 10 ms · settle &lt; 2 s after WAN drop · measured progress for every class</a:t>
+              <a:t>fewer inappropriate cuts than delay-only autorate · drop response ≤ comparator + 1 s · never worse than static SQM</a:t>
             </a:r>
           </a:p>
         </p:txBody>
@@ -7916,7 +7916,7 @@
                 </a:solidFill>
                 <a:latin typeface="Calibri"/>
               </a:rPr>
-              <a:t>Linux tc (CAKE; HTB later) · Python + pyroute2 control plane · LightGBM + conformal · Prometheus/Grafana · React + three.js · Playwright (WebRTC, dash.js) · iperf3 / irtt / Flent</a:t>
+              <a:t>Linux tc + nftables (CAKE; HFSC/HTB backends) · Go daemon veriqd on OpenWrt (procd, UCI, LuCI app) · Python harness + LightGBM/conformal training · three.js twin · Playwright (WebRTC, dash.js)</a:t>
             </a:r>
           </a:p>
           <a:p>
@@ -7941,7 +7941,7 @@
                 </a:solidFill>
                 <a:latin typeface="Calibri"/>
               </a:rPr>
-              <a:t>RDK-B / OpenWrt package · TR-181 + TR-369 USP fleet management · research tracks: eBPF datapath, Wi-Fi airtime, L4S, multi-gig scaling</a:t>
+              <a:t>OpenWrt packages (signed feed) · prplOS TR-181/USP and RDK-B with a partner · research tracks: L4S/NQB, Wi-Fi airtime, multi-gig</a:t>
             </a:r>
           </a:p>
         </p:txBody>

</xml_diff>